<commit_message>
Localize example place names to Indonesia; remove remaining Sdr./Sdri.
- Replace Japan/foreign city and landmark examples (Kyoto, Osaka,
  Tokyo, Hokkaido, Kobe, Nara, Beijing, Paris, Chiang Mai, Mt. Fuji,
  Koshien) across Minna 1 & 2 Bab 3-50 with Indonesian equivalents
  (Bandung, Surabaya, Jakarta, Lombok, Malang, Yogyakarta, Dieng,
  Medan, Solo, Mt. Bromo, Bogor). Country/language names (Jepang,
  bahasa Jepang, Bali) are left as-is per house style.
- Remove the remaining "Sdr. Nama" occurrences from Minna 1 & 2
  example translations (11 spots), matching the Bab 1 fix.
- Fix tools/slide-generator/cheatsheet_bab1.py, which still had the
  old "Sdr." wording even though the already-shipped cheatsheet PDF
  had been manually corrected — the checked-in generator now matches
  its output.
- Rebuild all 48 affected slide decks from the updated data.

Co-Authored-By: Claude Sonnet 5 <noreply@anthropic.com>
Claude-Session: https://claude.ai/code/session_01R2r5CpV1mHfrPgo3fPN6U9
</commit_message>
<xml_diff>
--- a/Modul Minna 1/Bab 13/38. Minna 1 Tata Bahasa Bab 13 - Slide.pptx
+++ b/Modul Minna 1/Bab 13/38. Minna 1 Tata Bahasa Bab 13 - Slide.pptx
@@ -3402,7 +3402,7 @@
                 <a:ea typeface="Arial" pitchFamily="34" charset="-122"/>
                 <a:cs typeface="Arial" pitchFamily="34" charset="-120"/>
               </a:rPr>
-              <a:t>こうべへえいがをみにいきます。</a:t>
+              <a:t>マランへえいがをみにいきます。</a:t>
             </a:r>
             <a:endParaRPr lang="en-US" sz="1700" dirty="0"/>
           </a:p>
@@ -3441,7 +3441,7 @@
                 <a:ea typeface="Arial" pitchFamily="34" charset="-122"/>
                 <a:cs typeface="Arial" pitchFamily="34" charset="-120"/>
               </a:rPr>
-              <a:t>Koube e eiga o mi ni ikimasu</a:t>
+              <a:t>Maran e eiga o mi ni ikimasu</a:t>
             </a:r>
             <a:pPr indent="0" marL="0">
               <a:buNone/>
@@ -3469,7 +3469,7 @@
                 <a:ea typeface="Arial" pitchFamily="34" charset="-122"/>
                 <a:cs typeface="Arial" pitchFamily="34" charset="-120"/>
               </a:rPr>
-              <a:t>Pergi ke Kobe untuk nonton film.</a:t>
+              <a:t>Pergi ke Malang untuk nonton film.</a:t>
             </a:r>
             <a:endParaRPr lang="en-US" sz="950" dirty="0"/>
           </a:p>

</xml_diff>